<commit_message>
Add the JournalCache logo and GitHub branch to the architecture slides.
</commit_message>
<xml_diff>
--- a/docs/JournalCache-architecture-slides.pptx
+++ b/docs/JournalCache-architecture-slides.pptx
@@ -3137,7 +3137,7 @@
       </p:pic>
       <p:pic>
         <p:nvPicPr>
-          <p:cNvPr id="3" name="Picture 2" descr="cern-logo.svg.png"/>
+          <p:cNvPr id="3" name="Picture 2" descr="journalcache-logo.png"/>
           <p:cNvPicPr>
             <a:picLocks noChangeAspect="1"/>
           </p:cNvPicPr>
@@ -3151,6 +3151,30 @@
         </p:blipFill>
         <p:spPr>
           <a:xfrm>
+            <a:off x="960120" y="109728"/>
+            <a:ext cx="699496" cy="566928"/>
+          </a:xfrm>
+          <a:prstGeom prst="rect">
+            <a:avLst/>
+          </a:prstGeom>
+        </p:spPr>
+      </p:pic>
+      <p:pic>
+        <p:nvPicPr>
+          <p:cNvPr id="4" name="Picture 3" descr="cern-logo.svg.png"/>
+          <p:cNvPicPr>
+            <a:picLocks noChangeAspect="1"/>
+          </p:cNvPicPr>
+          <p:nvPr/>
+        </p:nvPicPr>
+        <p:blipFill>
+          <a:blip r:embed="rId4"/>
+          <a:stretch>
+            <a:fillRect/>
+          </a:stretch>
+        </p:blipFill>
+        <p:spPr>
+          <a:xfrm>
             <a:off x="11384280" y="164592"/>
             <a:ext cx="475488" cy="475488"/>
           </a:xfrm>
@@ -3161,7 +3185,7 @@
       </p:pic>
       <p:sp>
         <p:nvSpPr>
-          <p:cNvPr id="4" name="Rectangle 3"/>
+          <p:cNvPr id="5" name="Rectangle 4"/>
           <p:cNvSpPr/>
           <p:nvPr/>
         </p:nvSpPr>
@@ -3204,7 +3228,7 @@
       </p:sp>
       <p:sp>
         <p:nvSpPr>
-          <p:cNvPr id="5" name="Rectangle 4"/>
+          <p:cNvPr id="6" name="Rectangle 5"/>
           <p:cNvSpPr/>
           <p:nvPr/>
         </p:nvSpPr>
@@ -3247,7 +3271,7 @@
       </p:sp>
       <p:sp>
         <p:nvSpPr>
-          <p:cNvPr id="6" name="TextBox 5"/>
+          <p:cNvPr id="7" name="TextBox 6"/>
           <p:cNvSpPr txBox="1"/>
           <p:nvPr/>
         </p:nvSpPr>
@@ -3280,16 +3304,40 @@
           </a:p>
         </p:txBody>
       </p:sp>
-      <p:sp>
-        <p:nvSpPr>
-          <p:cNvPr id="7" name="TextBox 6"/>
+      <p:pic>
+        <p:nvPicPr>
+          <p:cNvPr id="8" name="Picture 7" descr="journalcache-logo.png"/>
+          <p:cNvPicPr>
+            <a:picLocks noChangeAspect="1"/>
+          </p:cNvPicPr>
+          <p:nvPr/>
+        </p:nvPicPr>
+        <p:blipFill>
+          <a:blip r:embed="rId3"/>
+          <a:stretch>
+            <a:fillRect/>
+          </a:stretch>
+        </p:blipFill>
+        <p:spPr>
+          <a:xfrm>
+            <a:off x="822960" y="1143000"/>
+            <a:ext cx="2335412" cy="1892807"/>
+          </a:xfrm>
+          <a:prstGeom prst="rect">
+            <a:avLst/>
+          </a:prstGeom>
+        </p:spPr>
+      </p:pic>
+      <p:sp>
+        <p:nvSpPr>
+          <p:cNvPr id="9" name="TextBox 8"/>
           <p:cNvSpPr txBox="1"/>
           <p:nvPr/>
         </p:nvSpPr>
         <p:spPr>
           <a:xfrm>
-            <a:off x="822960" y="2194560"/>
-            <a:ext cx="10515600" cy="1280160"/>
+            <a:off x="3383280" y="1417320"/>
+            <a:ext cx="7863840" cy="1051560"/>
           </a:xfrm>
           <a:prstGeom prst="rect">
             <a:avLst/>
@@ -3317,13 +3365,13 @@
       </p:sp>
       <p:sp>
         <p:nvSpPr>
-          <p:cNvPr id="8" name="Rectangle 7"/>
+          <p:cNvPr id="10" name="Rectangle 9"/>
           <p:cNvSpPr/>
           <p:nvPr/>
         </p:nvSpPr>
         <p:spPr>
           <a:xfrm>
-            <a:off x="822960" y="3520440"/>
+            <a:off x="3383280" y="2606040"/>
             <a:ext cx="1463040" cy="38100"/>
           </a:xfrm>
           <a:prstGeom prst="rect">
@@ -3360,14 +3408,14 @@
       </p:sp>
       <p:sp>
         <p:nvSpPr>
-          <p:cNvPr id="9" name="TextBox 8"/>
+          <p:cNvPr id="11" name="TextBox 10"/>
           <p:cNvSpPr txBox="1"/>
           <p:nvPr/>
         </p:nvSpPr>
         <p:spPr>
           <a:xfrm>
-            <a:off x="822960" y="3749039"/>
-            <a:ext cx="10058400" cy="365760"/>
+            <a:off x="3383280" y="2880360"/>
+            <a:ext cx="7863840" cy="365760"/>
           </a:xfrm>
           <a:prstGeom prst="rect">
             <a:avLst/>
@@ -3388,21 +3436,21 @@
                 </a:solidFill>
                 <a:latin typeface="Calibri"/>
               </a:rPr>
-              <a:t>Dr. Andreas-Joachim Peters — CERN IT-SD-PSS</a:t>
-            </a:r>
-          </a:p>
-        </p:txBody>
-      </p:sp>
-      <p:sp>
-        <p:nvSpPr>
-          <p:cNvPr id="10" name="TextBox 9"/>
+              <a:t>Dr. Andreas-Joachim Peters - CERN IT-SD-PSS</a:t>
+            </a:r>
+          </a:p>
+        </p:txBody>
+      </p:sp>
+      <p:sp>
+        <p:nvSpPr>
+          <p:cNvPr id="12" name="TextBox 11"/>
           <p:cNvSpPr txBox="1"/>
           <p:nvPr/>
         </p:nvSpPr>
         <p:spPr>
           <a:xfrm>
-            <a:off x="822960" y="4160520"/>
-            <a:ext cx="10058400" cy="320040"/>
+            <a:off x="3383280" y="3291840"/>
+            <a:ext cx="7863840" cy="320040"/>
           </a:xfrm>
           <a:prstGeom prst="rect">
             <a:avLst/>
@@ -3424,6 +3472,42 @@
                 <a:latin typeface="Calibri"/>
               </a:rPr>
               <a:t>XROOTD WORKSHOP LYON 2026</a:t>
+            </a:r>
+          </a:p>
+        </p:txBody>
+      </p:sp>
+      <p:sp>
+        <p:nvSpPr>
+          <p:cNvPr id="13" name="TextBox 12"/>
+          <p:cNvSpPr txBox="1"/>
+          <p:nvPr/>
+        </p:nvSpPr>
+        <p:spPr>
+          <a:xfrm>
+            <a:off x="3383280" y="3794760"/>
+            <a:ext cx="7863840" cy="320040"/>
+          </a:xfrm>
+          <a:prstGeom prst="rect">
+            <a:avLst/>
+          </a:prstGeom>
+          <a:noFill/>
+        </p:spPr>
+        <p:txBody>
+          <a:bodyPr wrap="square">
+            <a:spAutoFit/>
+          </a:bodyPr>
+          <a:lstStyle/>
+          <a:p>
+            <a:pPr algn="l"/>
+            <a:r>
+              <a:rPr sz="1600" b="0" i="0">
+                <a:solidFill>
+                  <a:srgbClr val="B8923A"/>
+                </a:solidFill>
+                <a:latin typeface="Calibri"/>
+                <a:hlinkClick r:id="rId5"/>
+              </a:rPr>
+              <a:t>github.com/cern-eos/xrootd - XrdClJournalCachePlugin</a:t>
             </a:r>
           </a:p>
         </p:txBody>
@@ -3480,7 +3564,7 @@
       </p:pic>
       <p:pic>
         <p:nvPicPr>
-          <p:cNvPr id="3" name="Picture 2" descr="cern-logo.svg.png"/>
+          <p:cNvPr id="3" name="Picture 2" descr="journalcache-logo.png"/>
           <p:cNvPicPr>
             <a:picLocks noChangeAspect="1"/>
           </p:cNvPicPr>
@@ -3494,6 +3578,30 @@
         </p:blipFill>
         <p:spPr>
           <a:xfrm>
+            <a:off x="960120" y="109728"/>
+            <a:ext cx="699496" cy="566928"/>
+          </a:xfrm>
+          <a:prstGeom prst="rect">
+            <a:avLst/>
+          </a:prstGeom>
+        </p:spPr>
+      </p:pic>
+      <p:pic>
+        <p:nvPicPr>
+          <p:cNvPr id="4" name="Picture 3" descr="cern-logo.svg.png"/>
+          <p:cNvPicPr>
+            <a:picLocks noChangeAspect="1"/>
+          </p:cNvPicPr>
+          <p:nvPr/>
+        </p:nvPicPr>
+        <p:blipFill>
+          <a:blip r:embed="rId4"/>
+          <a:stretch>
+            <a:fillRect/>
+          </a:stretch>
+        </p:blipFill>
+        <p:spPr>
+          <a:xfrm>
             <a:off x="11384280" y="164592"/>
             <a:ext cx="475488" cy="475488"/>
           </a:xfrm>
@@ -3504,7 +3612,7 @@
       </p:pic>
       <p:sp>
         <p:nvSpPr>
-          <p:cNvPr id="4" name="Rectangle 3"/>
+          <p:cNvPr id="5" name="Rectangle 4"/>
           <p:cNvSpPr/>
           <p:nvPr/>
         </p:nvSpPr>
@@ -3547,7 +3655,7 @@
       </p:sp>
       <p:sp>
         <p:nvSpPr>
-          <p:cNvPr id="5" name="Rectangle 4"/>
+          <p:cNvPr id="6" name="Rectangle 5"/>
           <p:cNvSpPr/>
           <p:nvPr/>
         </p:nvSpPr>
@@ -3590,7 +3698,7 @@
       </p:sp>
       <p:sp>
         <p:nvSpPr>
-          <p:cNvPr id="6" name="TextBox 5"/>
+          <p:cNvPr id="7" name="TextBox 6"/>
           <p:cNvSpPr txBox="1"/>
           <p:nvPr/>
         </p:nvSpPr>
@@ -3625,7 +3733,7 @@
       </p:sp>
       <p:sp>
         <p:nvSpPr>
-          <p:cNvPr id="7" name="TextBox 6"/>
+          <p:cNvPr id="8" name="TextBox 7"/>
           <p:cNvSpPr txBox="1"/>
           <p:nvPr/>
         </p:nvSpPr>
@@ -3660,7 +3768,7 @@
       </p:sp>
       <p:sp>
         <p:nvSpPr>
-          <p:cNvPr id="8" name="TextBox 7"/>
+          <p:cNvPr id="9" name="TextBox 8"/>
           <p:cNvSpPr txBox="1"/>
           <p:nvPr/>
         </p:nvSpPr>
@@ -3695,7 +3803,7 @@
       </p:sp>
       <p:sp>
         <p:nvSpPr>
-          <p:cNvPr id="9" name="Rounded Rectangle 8"/>
+          <p:cNvPr id="10" name="Rounded Rectangle 9"/>
           <p:cNvSpPr/>
           <p:nvPr/>
         </p:nvSpPr>
@@ -3740,7 +3848,7 @@
       </p:sp>
       <p:sp>
         <p:nvSpPr>
-          <p:cNvPr id="10" name="TextBox 9"/>
+          <p:cNvPr id="11" name="TextBox 10"/>
           <p:cNvSpPr txBox="1"/>
           <p:nvPr/>
         </p:nvSpPr>
@@ -3775,7 +3883,7 @@
       </p:sp>
       <p:sp>
         <p:nvSpPr>
-          <p:cNvPr id="11" name="TextBox 10"/>
+          <p:cNvPr id="12" name="TextBox 11"/>
           <p:cNvSpPr txBox="1"/>
           <p:nvPr/>
         </p:nvSpPr>
@@ -3810,7 +3918,7 @@
       </p:sp>
       <p:sp>
         <p:nvSpPr>
-          <p:cNvPr id="12" name="TextBox 11"/>
+          <p:cNvPr id="13" name="TextBox 12"/>
           <p:cNvSpPr txBox="1"/>
           <p:nvPr/>
         </p:nvSpPr>
@@ -3897,7 +4005,7 @@
       </p:sp>
       <p:sp>
         <p:nvSpPr>
-          <p:cNvPr id="13" name="Rounded Rectangle 12"/>
+          <p:cNvPr id="14" name="Rounded Rectangle 13"/>
           <p:cNvSpPr/>
           <p:nvPr/>
         </p:nvSpPr>
@@ -3942,7 +4050,7 @@
       </p:sp>
       <p:sp>
         <p:nvSpPr>
-          <p:cNvPr id="14" name="TextBox 13"/>
+          <p:cNvPr id="15" name="TextBox 14"/>
           <p:cNvSpPr txBox="1"/>
           <p:nvPr/>
         </p:nvSpPr>
@@ -3977,7 +4085,7 @@
       </p:sp>
       <p:sp>
         <p:nvSpPr>
-          <p:cNvPr id="15" name="TextBox 14"/>
+          <p:cNvPr id="16" name="TextBox 15"/>
           <p:cNvSpPr txBox="1"/>
           <p:nvPr/>
         </p:nvSpPr>
@@ -4012,7 +4120,7 @@
       </p:sp>
       <p:sp>
         <p:nvSpPr>
-          <p:cNvPr id="16" name="TextBox 15"/>
+          <p:cNvPr id="17" name="TextBox 16"/>
           <p:cNvSpPr txBox="1"/>
           <p:nvPr/>
         </p:nvSpPr>
@@ -4044,7 +4152,7 @@
                 </a:solidFill>
                 <a:latin typeface="Calibri"/>
               </a:rPr>
-              <a:t>• init — state, units, TLS ports</a:t>
+              <a:t>• init - state, units, TLS ports</a:t>
             </a:r>
           </a:p>
           <a:p>
@@ -4099,7 +4207,7 @@
       </p:sp>
       <p:sp>
         <p:nvSpPr>
-          <p:cNvPr id="17" name="Rounded Rectangle 16"/>
+          <p:cNvPr id="18" name="Rounded Rectangle 17"/>
           <p:cNvSpPr/>
           <p:nvPr/>
         </p:nvSpPr>
@@ -4144,7 +4252,7 @@
       </p:sp>
       <p:sp>
         <p:nvSpPr>
-          <p:cNvPr id="18" name="TextBox 17"/>
+          <p:cNvPr id="19" name="TextBox 18"/>
           <p:cNvSpPr txBox="1"/>
           <p:nvPr/>
         </p:nvSpPr>
@@ -4179,7 +4287,7 @@
       </p:sp>
       <p:sp>
         <p:nvSpPr>
-          <p:cNvPr id="19" name="TextBox 18"/>
+          <p:cNvPr id="20" name="TextBox 19"/>
           <p:cNvSpPr txBox="1"/>
           <p:nvPr/>
         </p:nvSpPr>
@@ -4214,7 +4322,7 @@
       </p:sp>
       <p:sp>
         <p:nvSpPr>
-          <p:cNvPr id="20" name="TextBox 19"/>
+          <p:cNvPr id="21" name="TextBox 20"/>
           <p:cNvSpPr txBox="1"/>
           <p:nvPr/>
         </p:nvSpPr>
@@ -4351,7 +4459,7 @@
       </p:pic>
       <p:pic>
         <p:nvPicPr>
-          <p:cNvPr id="3" name="Picture 2" descr="cern-logo.svg.png"/>
+          <p:cNvPr id="3" name="Picture 2" descr="journalcache-logo.png"/>
           <p:cNvPicPr>
             <a:picLocks noChangeAspect="1"/>
           </p:cNvPicPr>
@@ -4365,6 +4473,30 @@
         </p:blipFill>
         <p:spPr>
           <a:xfrm>
+            <a:off x="960120" y="109728"/>
+            <a:ext cx="699496" cy="566928"/>
+          </a:xfrm>
+          <a:prstGeom prst="rect">
+            <a:avLst/>
+          </a:prstGeom>
+        </p:spPr>
+      </p:pic>
+      <p:pic>
+        <p:nvPicPr>
+          <p:cNvPr id="4" name="Picture 3" descr="cern-logo.svg.png"/>
+          <p:cNvPicPr>
+            <a:picLocks noChangeAspect="1"/>
+          </p:cNvPicPr>
+          <p:nvPr/>
+        </p:nvPicPr>
+        <p:blipFill>
+          <a:blip r:embed="rId4"/>
+          <a:stretch>
+            <a:fillRect/>
+          </a:stretch>
+        </p:blipFill>
+        <p:spPr>
+          <a:xfrm>
             <a:off x="11384280" y="164592"/>
             <a:ext cx="475488" cy="475488"/>
           </a:xfrm>
@@ -4375,7 +4507,7 @@
       </p:pic>
       <p:sp>
         <p:nvSpPr>
-          <p:cNvPr id="4" name="Rectangle 3"/>
+          <p:cNvPr id="5" name="Rectangle 4"/>
           <p:cNvSpPr/>
           <p:nvPr/>
         </p:nvSpPr>
@@ -4418,7 +4550,7 @@
       </p:sp>
       <p:sp>
         <p:nvSpPr>
-          <p:cNvPr id="5" name="Rectangle 4"/>
+          <p:cNvPr id="6" name="Rectangle 5"/>
           <p:cNvSpPr/>
           <p:nvPr/>
         </p:nvSpPr>
@@ -4461,7 +4593,7 @@
       </p:sp>
       <p:sp>
         <p:nvSpPr>
-          <p:cNvPr id="6" name="TextBox 5"/>
+          <p:cNvPr id="7" name="TextBox 6"/>
           <p:cNvSpPr txBox="1"/>
           <p:nvPr/>
         </p:nvSpPr>
@@ -4496,7 +4628,7 @@
       </p:sp>
       <p:sp>
         <p:nvSpPr>
-          <p:cNvPr id="7" name="TextBox 6"/>
+          <p:cNvPr id="8" name="TextBox 7"/>
           <p:cNvSpPr txBox="1"/>
           <p:nvPr/>
         </p:nvSpPr>
@@ -4531,7 +4663,7 @@
       </p:sp>
       <p:sp>
         <p:nvSpPr>
-          <p:cNvPr id="8" name="TextBox 7"/>
+          <p:cNvPr id="9" name="TextBox 8"/>
           <p:cNvSpPr txBox="1"/>
           <p:nvPr/>
         </p:nvSpPr>
@@ -4566,7 +4698,7 @@
       </p:sp>
       <p:sp>
         <p:nvSpPr>
-          <p:cNvPr id="9" name="TextBox 8"/>
+          <p:cNvPr id="10" name="TextBox 9"/>
           <p:cNvSpPr txBox="1"/>
           <p:nvPr/>
         </p:nvSpPr>
@@ -4601,7 +4733,7 @@
       </p:sp>
       <p:sp>
         <p:nvSpPr>
-          <p:cNvPr id="10" name="Rounded Rectangle 9"/>
+          <p:cNvPr id="11" name="Rounded Rectangle 10"/>
           <p:cNvSpPr/>
           <p:nvPr/>
         </p:nvSpPr>
@@ -4646,7 +4778,7 @@
       </p:sp>
       <p:sp>
         <p:nvSpPr>
-          <p:cNvPr id="11" name="TextBox 10"/>
+          <p:cNvPr id="12" name="TextBox 11"/>
           <p:cNvSpPr txBox="1"/>
           <p:nvPr/>
         </p:nvSpPr>
@@ -4681,7 +4813,7 @@
       </p:sp>
       <p:sp>
         <p:nvSpPr>
-          <p:cNvPr id="12" name="TextBox 11"/>
+          <p:cNvPr id="13" name="TextBox 12"/>
           <p:cNvSpPr txBox="1"/>
           <p:nvPr/>
         </p:nvSpPr>
@@ -4720,7 +4852,7 @@
       </p:sp>
       <p:sp>
         <p:nvSpPr>
-          <p:cNvPr id="13" name="Rounded Rectangle 12"/>
+          <p:cNvPr id="14" name="Rounded Rectangle 13"/>
           <p:cNvSpPr/>
           <p:nvPr/>
         </p:nvSpPr>
@@ -4765,7 +4897,7 @@
       </p:sp>
       <p:sp>
         <p:nvSpPr>
-          <p:cNvPr id="14" name="TextBox 13"/>
+          <p:cNvPr id="15" name="TextBox 14"/>
           <p:cNvSpPr txBox="1"/>
           <p:nvPr/>
         </p:nvSpPr>
@@ -4800,7 +4932,7 @@
       </p:sp>
       <p:sp>
         <p:nvSpPr>
-          <p:cNvPr id="15" name="TextBox 14"/>
+          <p:cNvPr id="16" name="TextBox 15"/>
           <p:cNvSpPr txBox="1"/>
           <p:nvPr/>
         </p:nvSpPr>
@@ -4887,7 +5019,7 @@
       </p:sp>
       <p:sp>
         <p:nvSpPr>
-          <p:cNvPr id="16" name="Rounded Rectangle 15"/>
+          <p:cNvPr id="17" name="Rounded Rectangle 16"/>
           <p:cNvSpPr/>
           <p:nvPr/>
         </p:nvSpPr>
@@ -4932,7 +5064,7 @@
       </p:sp>
       <p:sp>
         <p:nvSpPr>
-          <p:cNvPr id="17" name="TextBox 16"/>
+          <p:cNvPr id="18" name="TextBox 17"/>
           <p:cNvSpPr txBox="1"/>
           <p:nvPr/>
         </p:nvSpPr>
@@ -4967,7 +5099,7 @@
       </p:sp>
       <p:sp>
         <p:nvSpPr>
-          <p:cNvPr id="18" name="TextBox 17"/>
+          <p:cNvPr id="19" name="TextBox 18"/>
           <p:cNvSpPr txBox="1"/>
           <p:nvPr/>
         </p:nvSpPr>
@@ -5056,7 +5188,7 @@
       </p:pic>
       <p:pic>
         <p:nvPicPr>
-          <p:cNvPr id="3" name="Picture 2" descr="cern-logo.svg.png"/>
+          <p:cNvPr id="3" name="Picture 2" descr="journalcache-logo.png"/>
           <p:cNvPicPr>
             <a:picLocks noChangeAspect="1"/>
           </p:cNvPicPr>
@@ -5070,6 +5202,30 @@
         </p:blipFill>
         <p:spPr>
           <a:xfrm>
+            <a:off x="960120" y="109728"/>
+            <a:ext cx="699496" cy="566928"/>
+          </a:xfrm>
+          <a:prstGeom prst="rect">
+            <a:avLst/>
+          </a:prstGeom>
+        </p:spPr>
+      </p:pic>
+      <p:pic>
+        <p:nvPicPr>
+          <p:cNvPr id="4" name="Picture 3" descr="cern-logo.svg.png"/>
+          <p:cNvPicPr>
+            <a:picLocks noChangeAspect="1"/>
+          </p:cNvPicPr>
+          <p:nvPr/>
+        </p:nvPicPr>
+        <p:blipFill>
+          <a:blip r:embed="rId4"/>
+          <a:stretch>
+            <a:fillRect/>
+          </a:stretch>
+        </p:blipFill>
+        <p:spPr>
+          <a:xfrm>
             <a:off x="11384280" y="164592"/>
             <a:ext cx="475488" cy="475488"/>
           </a:xfrm>
@@ -5080,7 +5236,7 @@
       </p:pic>
       <p:sp>
         <p:nvSpPr>
-          <p:cNvPr id="4" name="Rectangle 3"/>
+          <p:cNvPr id="5" name="Rectangle 4"/>
           <p:cNvSpPr/>
           <p:nvPr/>
         </p:nvSpPr>
@@ -5123,7 +5279,7 @@
       </p:sp>
       <p:sp>
         <p:nvSpPr>
-          <p:cNvPr id="5" name="Rectangle 4"/>
+          <p:cNvPr id="6" name="Rectangle 5"/>
           <p:cNvSpPr/>
           <p:nvPr/>
         </p:nvSpPr>
@@ -5166,7 +5322,7 @@
       </p:sp>
       <p:sp>
         <p:nvSpPr>
-          <p:cNvPr id="6" name="TextBox 5"/>
+          <p:cNvPr id="7" name="TextBox 6"/>
           <p:cNvSpPr txBox="1"/>
           <p:nvPr/>
         </p:nvSpPr>
@@ -5201,7 +5357,7 @@
       </p:sp>
       <p:sp>
         <p:nvSpPr>
-          <p:cNvPr id="7" name="TextBox 6"/>
+          <p:cNvPr id="8" name="TextBox 7"/>
           <p:cNvSpPr txBox="1"/>
           <p:nvPr/>
         </p:nvSpPr>
@@ -5236,7 +5392,7 @@
       </p:sp>
       <p:sp>
         <p:nvSpPr>
-          <p:cNvPr id="8" name="TextBox 7"/>
+          <p:cNvPr id="9" name="TextBox 8"/>
           <p:cNvSpPr txBox="1"/>
           <p:nvPr/>
         </p:nvSpPr>
@@ -5271,7 +5427,7 @@
       </p:sp>
       <p:sp>
         <p:nvSpPr>
-          <p:cNvPr id="9" name="Rounded Rectangle 8"/>
+          <p:cNvPr id="10" name="Rounded Rectangle 9"/>
           <p:cNvSpPr/>
           <p:nvPr/>
         </p:nvSpPr>
@@ -5316,7 +5472,7 @@
       </p:sp>
       <p:sp>
         <p:nvSpPr>
-          <p:cNvPr id="10" name="TextBox 9"/>
+          <p:cNvPr id="11" name="TextBox 10"/>
           <p:cNvSpPr txBox="1"/>
           <p:nvPr/>
         </p:nvSpPr>
@@ -5351,7 +5507,7 @@
       </p:sp>
       <p:sp>
         <p:nvSpPr>
-          <p:cNvPr id="11" name="TextBox 10"/>
+          <p:cNvPr id="12" name="TextBox 11"/>
           <p:cNvSpPr txBox="1"/>
           <p:nvPr/>
         </p:nvSpPr>
@@ -5386,7 +5542,7 @@
       </p:sp>
       <p:sp>
         <p:nvSpPr>
-          <p:cNvPr id="12" name="TextBox 11"/>
+          <p:cNvPr id="13" name="TextBox 12"/>
           <p:cNvSpPr txBox="1"/>
           <p:nvPr/>
         </p:nvSpPr>
@@ -5489,7 +5645,7 @@
       </p:sp>
       <p:sp>
         <p:nvSpPr>
-          <p:cNvPr id="13" name="Rounded Rectangle 12"/>
+          <p:cNvPr id="14" name="Rounded Rectangle 13"/>
           <p:cNvSpPr/>
           <p:nvPr/>
         </p:nvSpPr>
@@ -5534,7 +5690,7 @@
       </p:sp>
       <p:sp>
         <p:nvSpPr>
-          <p:cNvPr id="14" name="TextBox 13"/>
+          <p:cNvPr id="15" name="TextBox 14"/>
           <p:cNvSpPr txBox="1"/>
           <p:nvPr/>
         </p:nvSpPr>
@@ -5569,7 +5725,7 @@
       </p:sp>
       <p:sp>
         <p:nvSpPr>
-          <p:cNvPr id="15" name="TextBox 14"/>
+          <p:cNvPr id="16" name="TextBox 15"/>
           <p:cNvSpPr txBox="1"/>
           <p:nvPr/>
         </p:nvSpPr>
@@ -5604,7 +5760,7 @@
       </p:sp>
       <p:sp>
         <p:nvSpPr>
-          <p:cNvPr id="16" name="TextBox 15"/>
+          <p:cNvPr id="17" name="TextBox 16"/>
           <p:cNvSpPr txBox="1"/>
           <p:nvPr/>
         </p:nvSpPr>
@@ -5757,7 +5913,7 @@
       </p:pic>
       <p:pic>
         <p:nvPicPr>
-          <p:cNvPr id="3" name="Picture 2" descr="cern-logo.svg.png"/>
+          <p:cNvPr id="3" name="Picture 2" descr="journalcache-logo.png"/>
           <p:cNvPicPr>
             <a:picLocks noChangeAspect="1"/>
           </p:cNvPicPr>
@@ -5771,6 +5927,30 @@
         </p:blipFill>
         <p:spPr>
           <a:xfrm>
+            <a:off x="960120" y="109728"/>
+            <a:ext cx="699496" cy="566928"/>
+          </a:xfrm>
+          <a:prstGeom prst="rect">
+            <a:avLst/>
+          </a:prstGeom>
+        </p:spPr>
+      </p:pic>
+      <p:pic>
+        <p:nvPicPr>
+          <p:cNvPr id="4" name="Picture 3" descr="cern-logo.svg.png"/>
+          <p:cNvPicPr>
+            <a:picLocks noChangeAspect="1"/>
+          </p:cNvPicPr>
+          <p:nvPr/>
+        </p:nvPicPr>
+        <p:blipFill>
+          <a:blip r:embed="rId4"/>
+          <a:stretch>
+            <a:fillRect/>
+          </a:stretch>
+        </p:blipFill>
+        <p:spPr>
+          <a:xfrm>
             <a:off x="11384280" y="164592"/>
             <a:ext cx="475488" cy="475488"/>
           </a:xfrm>
@@ -5781,7 +5961,7 @@
       </p:pic>
       <p:sp>
         <p:nvSpPr>
-          <p:cNvPr id="4" name="Rectangle 3"/>
+          <p:cNvPr id="5" name="Rectangle 4"/>
           <p:cNvSpPr/>
           <p:nvPr/>
         </p:nvSpPr>
@@ -5824,7 +6004,7 @@
       </p:sp>
       <p:sp>
         <p:nvSpPr>
-          <p:cNvPr id="5" name="Rectangle 4"/>
+          <p:cNvPr id="6" name="Rectangle 5"/>
           <p:cNvSpPr/>
           <p:nvPr/>
         </p:nvSpPr>
@@ -5867,7 +6047,7 @@
       </p:sp>
       <p:sp>
         <p:nvSpPr>
-          <p:cNvPr id="6" name="TextBox 5"/>
+          <p:cNvPr id="7" name="TextBox 6"/>
           <p:cNvSpPr txBox="1"/>
           <p:nvPr/>
         </p:nvSpPr>
@@ -5902,7 +6082,7 @@
       </p:sp>
       <p:sp>
         <p:nvSpPr>
-          <p:cNvPr id="7" name="TextBox 6"/>
+          <p:cNvPr id="8" name="TextBox 7"/>
           <p:cNvSpPr txBox="1"/>
           <p:nvPr/>
         </p:nvSpPr>
@@ -5937,7 +6117,7 @@
       </p:sp>
       <p:sp>
         <p:nvSpPr>
-          <p:cNvPr id="8" name="TextBox 7"/>
+          <p:cNvPr id="9" name="TextBox 8"/>
           <p:cNvSpPr txBox="1"/>
           <p:nvPr/>
         </p:nvSpPr>
@@ -5972,7 +6152,7 @@
       </p:sp>
       <p:graphicFrame>
         <p:nvGraphicFramePr>
-          <p:cNvPr id="9" name="Table 8"/>
+          <p:cNvPr id="10" name="Table 9"/>
           <p:cNvGraphicFramePr>
             <a:graphicFrameLocks noGrp="1"/>
           </p:cNvGraphicFramePr>
@@ -6688,7 +6868,7 @@
       </p:pic>
       <p:pic>
         <p:nvPicPr>
-          <p:cNvPr id="3" name="Picture 2" descr="cern-logo.svg.png"/>
+          <p:cNvPr id="3" name="Picture 2" descr="journalcache-logo.png"/>
           <p:cNvPicPr>
             <a:picLocks noChangeAspect="1"/>
           </p:cNvPicPr>
@@ -6702,6 +6882,30 @@
         </p:blipFill>
         <p:spPr>
           <a:xfrm>
+            <a:off x="960120" y="109728"/>
+            <a:ext cx="699496" cy="566928"/>
+          </a:xfrm>
+          <a:prstGeom prst="rect">
+            <a:avLst/>
+          </a:prstGeom>
+        </p:spPr>
+      </p:pic>
+      <p:pic>
+        <p:nvPicPr>
+          <p:cNvPr id="4" name="Picture 3" descr="cern-logo.svg.png"/>
+          <p:cNvPicPr>
+            <a:picLocks noChangeAspect="1"/>
+          </p:cNvPicPr>
+          <p:nvPr/>
+        </p:nvPicPr>
+        <p:blipFill>
+          <a:blip r:embed="rId4"/>
+          <a:stretch>
+            <a:fillRect/>
+          </a:stretch>
+        </p:blipFill>
+        <p:spPr>
+          <a:xfrm>
             <a:off x="11384280" y="164592"/>
             <a:ext cx="475488" cy="475488"/>
           </a:xfrm>
@@ -6712,7 +6916,7 @@
       </p:pic>
       <p:sp>
         <p:nvSpPr>
-          <p:cNvPr id="4" name="Rectangle 3"/>
+          <p:cNvPr id="5" name="Rectangle 4"/>
           <p:cNvSpPr/>
           <p:nvPr/>
         </p:nvSpPr>
@@ -6755,7 +6959,7 @@
       </p:sp>
       <p:sp>
         <p:nvSpPr>
-          <p:cNvPr id="5" name="Rectangle 4"/>
+          <p:cNvPr id="6" name="Rectangle 5"/>
           <p:cNvSpPr/>
           <p:nvPr/>
         </p:nvSpPr>
@@ -6798,7 +7002,7 @@
       </p:sp>
       <p:sp>
         <p:nvSpPr>
-          <p:cNvPr id="6" name="TextBox 5"/>
+          <p:cNvPr id="7" name="TextBox 6"/>
           <p:cNvSpPr txBox="1"/>
           <p:nvPr/>
         </p:nvSpPr>
@@ -6833,7 +7037,7 @@
       </p:sp>
       <p:sp>
         <p:nvSpPr>
-          <p:cNvPr id="7" name="TextBox 6"/>
+          <p:cNvPr id="8" name="TextBox 7"/>
           <p:cNvSpPr txBox="1"/>
           <p:nvPr/>
         </p:nvSpPr>
@@ -6868,7 +7072,7 @@
       </p:sp>
       <p:sp>
         <p:nvSpPr>
-          <p:cNvPr id="8" name="TextBox 7"/>
+          <p:cNvPr id="9" name="TextBox 8"/>
           <p:cNvSpPr txBox="1"/>
           <p:nvPr/>
         </p:nvSpPr>
@@ -6903,7 +7107,7 @@
       </p:sp>
       <p:sp>
         <p:nvSpPr>
-          <p:cNvPr id="9" name="TextBox 8"/>
+          <p:cNvPr id="10" name="TextBox 9"/>
           <p:cNvSpPr txBox="1"/>
           <p:nvPr/>
         </p:nvSpPr>
@@ -6938,7 +7142,7 @@
       </p:sp>
       <p:sp>
         <p:nvSpPr>
-          <p:cNvPr id="10" name="Rounded Rectangle 9"/>
+          <p:cNvPr id="11" name="Rounded Rectangle 10"/>
           <p:cNvSpPr/>
           <p:nvPr/>
         </p:nvSpPr>
@@ -6983,7 +7187,7 @@
       </p:sp>
       <p:sp>
         <p:nvSpPr>
-          <p:cNvPr id="11" name="TextBox 10"/>
+          <p:cNvPr id="12" name="TextBox 11"/>
           <p:cNvSpPr txBox="1"/>
           <p:nvPr/>
         </p:nvSpPr>
@@ -7018,7 +7222,7 @@
       </p:sp>
       <p:sp>
         <p:nvSpPr>
-          <p:cNvPr id="12" name="TextBox 11"/>
+          <p:cNvPr id="13" name="TextBox 12"/>
           <p:cNvSpPr txBox="1"/>
           <p:nvPr/>
         </p:nvSpPr>
@@ -7053,7 +7257,7 @@
       </p:sp>
       <p:sp>
         <p:nvSpPr>
-          <p:cNvPr id="13" name="TextBox 12"/>
+          <p:cNvPr id="14" name="TextBox 13"/>
           <p:cNvSpPr txBox="1"/>
           <p:nvPr/>
         </p:nvSpPr>
@@ -7156,7 +7360,7 @@
       </p:sp>
       <p:sp>
         <p:nvSpPr>
-          <p:cNvPr id="14" name="Rounded Rectangle 13"/>
+          <p:cNvPr id="15" name="Rounded Rectangle 14"/>
           <p:cNvSpPr/>
           <p:nvPr/>
         </p:nvSpPr>
@@ -7201,7 +7405,7 @@
       </p:sp>
       <p:sp>
         <p:nvSpPr>
-          <p:cNvPr id="15" name="TextBox 14"/>
+          <p:cNvPr id="16" name="TextBox 15"/>
           <p:cNvSpPr txBox="1"/>
           <p:nvPr/>
         </p:nvSpPr>
@@ -7236,7 +7440,7 @@
       </p:sp>
       <p:sp>
         <p:nvSpPr>
-          <p:cNvPr id="16" name="TextBox 15"/>
+          <p:cNvPr id="17" name="TextBox 16"/>
           <p:cNvSpPr txBox="1"/>
           <p:nvPr/>
         </p:nvSpPr>
@@ -7271,7 +7475,7 @@
       </p:sp>
       <p:sp>
         <p:nvSpPr>
-          <p:cNvPr id="17" name="TextBox 16"/>
+          <p:cNvPr id="18" name="TextBox 17"/>
           <p:cNvSpPr txBox="1"/>
           <p:nvPr/>
         </p:nvSpPr>
@@ -7424,7 +7628,7 @@
       </p:pic>
       <p:pic>
         <p:nvPicPr>
-          <p:cNvPr id="3" name="Picture 2" descr="cern-logo.svg.png"/>
+          <p:cNvPr id="3" name="Picture 2" descr="journalcache-logo.png"/>
           <p:cNvPicPr>
             <a:picLocks noChangeAspect="1"/>
           </p:cNvPicPr>
@@ -7438,6 +7642,30 @@
         </p:blipFill>
         <p:spPr>
           <a:xfrm>
+            <a:off x="960120" y="109728"/>
+            <a:ext cx="699496" cy="566928"/>
+          </a:xfrm>
+          <a:prstGeom prst="rect">
+            <a:avLst/>
+          </a:prstGeom>
+        </p:spPr>
+      </p:pic>
+      <p:pic>
+        <p:nvPicPr>
+          <p:cNvPr id="4" name="Picture 3" descr="cern-logo.svg.png"/>
+          <p:cNvPicPr>
+            <a:picLocks noChangeAspect="1"/>
+          </p:cNvPicPr>
+          <p:nvPr/>
+        </p:nvPicPr>
+        <p:blipFill>
+          <a:blip r:embed="rId4"/>
+          <a:stretch>
+            <a:fillRect/>
+          </a:stretch>
+        </p:blipFill>
+        <p:spPr>
+          <a:xfrm>
             <a:off x="11384280" y="164592"/>
             <a:ext cx="475488" cy="475488"/>
           </a:xfrm>
@@ -7448,7 +7676,7 @@
       </p:pic>
       <p:sp>
         <p:nvSpPr>
-          <p:cNvPr id="4" name="Rectangle 3"/>
+          <p:cNvPr id="5" name="Rectangle 4"/>
           <p:cNvSpPr/>
           <p:nvPr/>
         </p:nvSpPr>
@@ -7491,7 +7719,7 @@
       </p:sp>
       <p:sp>
         <p:nvSpPr>
-          <p:cNvPr id="5" name="Rectangle 4"/>
+          <p:cNvPr id="6" name="Rectangle 5"/>
           <p:cNvSpPr/>
           <p:nvPr/>
         </p:nvSpPr>
@@ -7534,7 +7762,7 @@
       </p:sp>
       <p:sp>
         <p:nvSpPr>
-          <p:cNvPr id="6" name="TextBox 5"/>
+          <p:cNvPr id="7" name="TextBox 6"/>
           <p:cNvSpPr txBox="1"/>
           <p:nvPr/>
         </p:nvSpPr>
@@ -7569,7 +7797,7 @@
       </p:sp>
       <p:sp>
         <p:nvSpPr>
-          <p:cNvPr id="7" name="TextBox 6"/>
+          <p:cNvPr id="8" name="TextBox 7"/>
           <p:cNvSpPr txBox="1"/>
           <p:nvPr/>
         </p:nvSpPr>
@@ -7604,7 +7832,7 @@
       </p:sp>
       <p:sp>
         <p:nvSpPr>
-          <p:cNvPr id="8" name="TextBox 7"/>
+          <p:cNvPr id="9" name="TextBox 8"/>
           <p:cNvSpPr txBox="1"/>
           <p:nvPr/>
         </p:nvSpPr>
@@ -7639,7 +7867,7 @@
       </p:sp>
       <p:graphicFrame>
         <p:nvGraphicFramePr>
-          <p:cNvPr id="9" name="Table 8"/>
+          <p:cNvPr id="10" name="Table 9"/>
           <p:cNvGraphicFramePr>
             <a:graphicFrameLocks noGrp="1"/>
           </p:cNvGraphicFramePr>
@@ -8099,7 +8327,7 @@
       </p:pic>
       <p:pic>
         <p:nvPicPr>
-          <p:cNvPr id="3" name="Picture 2" descr="cern-logo.svg.png"/>
+          <p:cNvPr id="3" name="Picture 2" descr="journalcache-logo.png"/>
           <p:cNvPicPr>
             <a:picLocks noChangeAspect="1"/>
           </p:cNvPicPr>
@@ -8113,6 +8341,30 @@
         </p:blipFill>
         <p:spPr>
           <a:xfrm>
+            <a:off x="960120" y="109728"/>
+            <a:ext cx="699496" cy="566928"/>
+          </a:xfrm>
+          <a:prstGeom prst="rect">
+            <a:avLst/>
+          </a:prstGeom>
+        </p:spPr>
+      </p:pic>
+      <p:pic>
+        <p:nvPicPr>
+          <p:cNvPr id="4" name="Picture 3" descr="cern-logo.svg.png"/>
+          <p:cNvPicPr>
+            <a:picLocks noChangeAspect="1"/>
+          </p:cNvPicPr>
+          <p:nvPr/>
+        </p:nvPicPr>
+        <p:blipFill>
+          <a:blip r:embed="rId4"/>
+          <a:stretch>
+            <a:fillRect/>
+          </a:stretch>
+        </p:blipFill>
+        <p:spPr>
+          <a:xfrm>
             <a:off x="11384280" y="164592"/>
             <a:ext cx="475488" cy="475488"/>
           </a:xfrm>
@@ -8123,7 +8375,7 @@
       </p:pic>
       <p:sp>
         <p:nvSpPr>
-          <p:cNvPr id="4" name="Rectangle 3"/>
+          <p:cNvPr id="5" name="Rectangle 4"/>
           <p:cNvSpPr/>
           <p:nvPr/>
         </p:nvSpPr>
@@ -8166,7 +8418,7 @@
       </p:sp>
       <p:sp>
         <p:nvSpPr>
-          <p:cNvPr id="5" name="Rectangle 4"/>
+          <p:cNvPr id="6" name="Rectangle 5"/>
           <p:cNvSpPr/>
           <p:nvPr/>
         </p:nvSpPr>
@@ -8209,7 +8461,7 @@
       </p:sp>
       <p:sp>
         <p:nvSpPr>
-          <p:cNvPr id="6" name="TextBox 5"/>
+          <p:cNvPr id="7" name="TextBox 6"/>
           <p:cNvSpPr txBox="1"/>
           <p:nvPr/>
         </p:nvSpPr>
@@ -8244,7 +8496,7 @@
       </p:sp>
       <p:sp>
         <p:nvSpPr>
-          <p:cNvPr id="7" name="TextBox 6"/>
+          <p:cNvPr id="8" name="TextBox 7"/>
           <p:cNvSpPr txBox="1"/>
           <p:nvPr/>
         </p:nvSpPr>
@@ -8279,7 +8531,7 @@
       </p:sp>
       <p:sp>
         <p:nvSpPr>
-          <p:cNvPr id="8" name="TextBox 7"/>
+          <p:cNvPr id="9" name="TextBox 8"/>
           <p:cNvSpPr txBox="1"/>
           <p:nvPr/>
         </p:nvSpPr>
@@ -8314,7 +8566,7 @@
       </p:sp>
       <p:sp>
         <p:nvSpPr>
-          <p:cNvPr id="9" name="Rounded Rectangle 8"/>
+          <p:cNvPr id="10" name="Rounded Rectangle 9"/>
           <p:cNvSpPr/>
           <p:nvPr/>
         </p:nvSpPr>
@@ -8359,7 +8611,7 @@
       </p:sp>
       <p:sp>
         <p:nvSpPr>
-          <p:cNvPr id="10" name="TextBox 9"/>
+          <p:cNvPr id="11" name="TextBox 10"/>
           <p:cNvSpPr txBox="1"/>
           <p:nvPr/>
         </p:nvSpPr>
@@ -8394,7 +8646,7 @@
       </p:sp>
       <p:sp>
         <p:nvSpPr>
-          <p:cNvPr id="11" name="TextBox 10"/>
+          <p:cNvPr id="12" name="TextBox 11"/>
           <p:cNvSpPr txBox="1"/>
           <p:nvPr/>
         </p:nvSpPr>
@@ -8429,7 +8681,7 @@
       </p:sp>
       <p:sp>
         <p:nvSpPr>
-          <p:cNvPr id="12" name="TextBox 11"/>
+          <p:cNvPr id="13" name="TextBox 12"/>
           <p:cNvSpPr txBox="1"/>
           <p:nvPr/>
         </p:nvSpPr>
@@ -8532,7 +8784,7 @@
       </p:sp>
       <p:sp>
         <p:nvSpPr>
-          <p:cNvPr id="13" name="Rounded Rectangle 12"/>
+          <p:cNvPr id="14" name="Rounded Rectangle 13"/>
           <p:cNvSpPr/>
           <p:nvPr/>
         </p:nvSpPr>
@@ -8577,7 +8829,7 @@
       </p:sp>
       <p:sp>
         <p:nvSpPr>
-          <p:cNvPr id="14" name="TextBox 13"/>
+          <p:cNvPr id="15" name="TextBox 14"/>
           <p:cNvSpPr txBox="1"/>
           <p:nvPr/>
         </p:nvSpPr>
@@ -8612,7 +8864,7 @@
       </p:sp>
       <p:sp>
         <p:nvSpPr>
-          <p:cNvPr id="15" name="TextBox 14"/>
+          <p:cNvPr id="16" name="TextBox 15"/>
           <p:cNvSpPr txBox="1"/>
           <p:nvPr/>
         </p:nvSpPr>
@@ -8647,7 +8899,7 @@
       </p:sp>
       <p:sp>
         <p:nvSpPr>
-          <p:cNvPr id="16" name="TextBox 15"/>
+          <p:cNvPr id="17" name="TextBox 16"/>
           <p:cNvSpPr txBox="1"/>
           <p:nvPr/>
         </p:nvSpPr>
@@ -8750,7 +9002,7 @@
       </p:sp>
       <p:sp>
         <p:nvSpPr>
-          <p:cNvPr id="17" name="Rounded Rectangle 16"/>
+          <p:cNvPr id="18" name="Rounded Rectangle 17"/>
           <p:cNvSpPr/>
           <p:nvPr/>
         </p:nvSpPr>
@@ -8795,7 +9047,7 @@
       </p:sp>
       <p:sp>
         <p:nvSpPr>
-          <p:cNvPr id="18" name="TextBox 17"/>
+          <p:cNvPr id="19" name="TextBox 18"/>
           <p:cNvSpPr txBox="1"/>
           <p:nvPr/>
         </p:nvSpPr>
@@ -8830,7 +9082,7 @@
       </p:sp>
       <p:sp>
         <p:nvSpPr>
-          <p:cNvPr id="19" name="TextBox 18"/>
+          <p:cNvPr id="20" name="TextBox 19"/>
           <p:cNvSpPr txBox="1"/>
           <p:nvPr/>
         </p:nvSpPr>
@@ -8865,7 +9117,7 @@
       </p:sp>
       <p:sp>
         <p:nvSpPr>
-          <p:cNvPr id="20" name="TextBox 19"/>
+          <p:cNvPr id="21" name="TextBox 20"/>
           <p:cNvSpPr txBox="1"/>
           <p:nvPr/>
         </p:nvSpPr>
@@ -8952,7 +9204,7 @@
       </p:sp>
       <p:sp>
         <p:nvSpPr>
-          <p:cNvPr id="21" name="TextBox 20"/>
+          <p:cNvPr id="22" name="TextBox 21"/>
           <p:cNvSpPr txBox="1"/>
           <p:nvPr/>
         </p:nvSpPr>
@@ -9037,7 +9289,7 @@
       </p:pic>
       <p:pic>
         <p:nvPicPr>
-          <p:cNvPr id="3" name="Picture 2" descr="cern-logo.svg.png"/>
+          <p:cNvPr id="3" name="Picture 2" descr="journalcache-logo.png"/>
           <p:cNvPicPr>
             <a:picLocks noChangeAspect="1"/>
           </p:cNvPicPr>
@@ -9051,6 +9303,30 @@
         </p:blipFill>
         <p:spPr>
           <a:xfrm>
+            <a:off x="960120" y="109728"/>
+            <a:ext cx="699496" cy="566928"/>
+          </a:xfrm>
+          <a:prstGeom prst="rect">
+            <a:avLst/>
+          </a:prstGeom>
+        </p:spPr>
+      </p:pic>
+      <p:pic>
+        <p:nvPicPr>
+          <p:cNvPr id="4" name="Picture 3" descr="cern-logo.svg.png"/>
+          <p:cNvPicPr>
+            <a:picLocks noChangeAspect="1"/>
+          </p:cNvPicPr>
+          <p:nvPr/>
+        </p:nvPicPr>
+        <p:blipFill>
+          <a:blip r:embed="rId4"/>
+          <a:stretch>
+            <a:fillRect/>
+          </a:stretch>
+        </p:blipFill>
+        <p:spPr>
+          <a:xfrm>
             <a:off x="11384280" y="164592"/>
             <a:ext cx="475488" cy="475488"/>
           </a:xfrm>
@@ -9061,7 +9337,7 @@
       </p:pic>
       <p:sp>
         <p:nvSpPr>
-          <p:cNvPr id="4" name="Rectangle 3"/>
+          <p:cNvPr id="5" name="Rectangle 4"/>
           <p:cNvSpPr/>
           <p:nvPr/>
         </p:nvSpPr>
@@ -9104,7 +9380,7 @@
       </p:sp>
       <p:sp>
         <p:nvSpPr>
-          <p:cNvPr id="5" name="Rectangle 4"/>
+          <p:cNvPr id="6" name="Rectangle 5"/>
           <p:cNvSpPr/>
           <p:nvPr/>
         </p:nvSpPr>
@@ -9147,7 +9423,7 @@
       </p:sp>
       <p:sp>
         <p:nvSpPr>
-          <p:cNvPr id="6" name="TextBox 5"/>
+          <p:cNvPr id="7" name="TextBox 6"/>
           <p:cNvSpPr txBox="1"/>
           <p:nvPr/>
         </p:nvSpPr>
@@ -9182,7 +9458,7 @@
       </p:sp>
       <p:sp>
         <p:nvSpPr>
-          <p:cNvPr id="7" name="TextBox 6"/>
+          <p:cNvPr id="8" name="TextBox 7"/>
           <p:cNvSpPr txBox="1"/>
           <p:nvPr/>
         </p:nvSpPr>
@@ -9217,7 +9493,7 @@
       </p:sp>
       <p:sp>
         <p:nvSpPr>
-          <p:cNvPr id="8" name="TextBox 7"/>
+          <p:cNvPr id="9" name="TextBox 8"/>
           <p:cNvSpPr txBox="1"/>
           <p:nvPr/>
         </p:nvSpPr>
@@ -9252,7 +9528,7 @@
       </p:sp>
       <p:sp>
         <p:nvSpPr>
-          <p:cNvPr id="9" name="TextBox 8"/>
+          <p:cNvPr id="10" name="TextBox 9"/>
           <p:cNvSpPr txBox="1"/>
           <p:nvPr/>
         </p:nvSpPr>
@@ -9287,7 +9563,7 @@
       </p:sp>
       <p:sp>
         <p:nvSpPr>
-          <p:cNvPr id="10" name="Rounded Rectangle 9"/>
+          <p:cNvPr id="11" name="Rounded Rectangle 10"/>
           <p:cNvSpPr/>
           <p:nvPr/>
         </p:nvSpPr>
@@ -9332,7 +9608,7 @@
       </p:sp>
       <p:sp>
         <p:nvSpPr>
-          <p:cNvPr id="11" name="TextBox 10"/>
+          <p:cNvPr id="12" name="TextBox 11"/>
           <p:cNvSpPr txBox="1"/>
           <p:nvPr/>
         </p:nvSpPr>
@@ -9367,7 +9643,7 @@
       </p:sp>
       <p:sp>
         <p:nvSpPr>
-          <p:cNvPr id="12" name="TextBox 11"/>
+          <p:cNvPr id="13" name="TextBox 12"/>
           <p:cNvSpPr txBox="1"/>
           <p:nvPr/>
         </p:nvSpPr>
@@ -9402,7 +9678,7 @@
       </p:sp>
       <p:sp>
         <p:nvSpPr>
-          <p:cNvPr id="13" name="TextBox 12"/>
+          <p:cNvPr id="14" name="TextBox 13"/>
           <p:cNvSpPr txBox="1"/>
           <p:nvPr/>
         </p:nvSpPr>
@@ -9441,7 +9717,7 @@
       </p:sp>
       <p:sp>
         <p:nvSpPr>
-          <p:cNvPr id="14" name="Rounded Rectangle 13"/>
+          <p:cNvPr id="15" name="Rounded Rectangle 14"/>
           <p:cNvSpPr/>
           <p:nvPr/>
         </p:nvSpPr>
@@ -9486,7 +9762,7 @@
       </p:sp>
       <p:sp>
         <p:nvSpPr>
-          <p:cNvPr id="15" name="TextBox 14"/>
+          <p:cNvPr id="16" name="TextBox 15"/>
           <p:cNvSpPr txBox="1"/>
           <p:nvPr/>
         </p:nvSpPr>
@@ -9521,7 +9797,7 @@
       </p:sp>
       <p:sp>
         <p:nvSpPr>
-          <p:cNvPr id="16" name="TextBox 15"/>
+          <p:cNvPr id="17" name="TextBox 16"/>
           <p:cNvSpPr txBox="1"/>
           <p:nvPr/>
         </p:nvSpPr>
@@ -9556,7 +9832,7 @@
       </p:sp>
       <p:sp>
         <p:nvSpPr>
-          <p:cNvPr id="17" name="TextBox 16"/>
+          <p:cNvPr id="18" name="TextBox 17"/>
           <p:cNvSpPr txBox="1"/>
           <p:nvPr/>
         </p:nvSpPr>
@@ -9595,7 +9871,7 @@
       </p:sp>
       <p:sp>
         <p:nvSpPr>
-          <p:cNvPr id="18" name="Rounded Rectangle 17"/>
+          <p:cNvPr id="19" name="Rounded Rectangle 18"/>
           <p:cNvSpPr/>
           <p:nvPr/>
         </p:nvSpPr>
@@ -9640,7 +9916,7 @@
       </p:sp>
       <p:sp>
         <p:nvSpPr>
-          <p:cNvPr id="19" name="TextBox 18"/>
+          <p:cNvPr id="20" name="TextBox 19"/>
           <p:cNvSpPr txBox="1"/>
           <p:nvPr/>
         </p:nvSpPr>
@@ -9675,7 +9951,7 @@
       </p:sp>
       <p:sp>
         <p:nvSpPr>
-          <p:cNvPr id="20" name="TextBox 19"/>
+          <p:cNvPr id="21" name="TextBox 20"/>
           <p:cNvSpPr txBox="1"/>
           <p:nvPr/>
         </p:nvSpPr>
@@ -9710,7 +9986,7 @@
       </p:sp>
       <p:sp>
         <p:nvSpPr>
-          <p:cNvPr id="21" name="TextBox 20"/>
+          <p:cNvPr id="22" name="TextBox 21"/>
           <p:cNvSpPr txBox="1"/>
           <p:nvPr/>
         </p:nvSpPr>
@@ -9799,7 +10075,7 @@
       </p:pic>
       <p:pic>
         <p:nvPicPr>
-          <p:cNvPr id="3" name="Picture 2" descr="cern-logo.svg.png"/>
+          <p:cNvPr id="3" name="Picture 2" descr="journalcache-logo.png"/>
           <p:cNvPicPr>
             <a:picLocks noChangeAspect="1"/>
           </p:cNvPicPr>
@@ -9813,6 +10089,30 @@
         </p:blipFill>
         <p:spPr>
           <a:xfrm>
+            <a:off x="960120" y="109728"/>
+            <a:ext cx="699496" cy="566928"/>
+          </a:xfrm>
+          <a:prstGeom prst="rect">
+            <a:avLst/>
+          </a:prstGeom>
+        </p:spPr>
+      </p:pic>
+      <p:pic>
+        <p:nvPicPr>
+          <p:cNvPr id="4" name="Picture 3" descr="cern-logo.svg.png"/>
+          <p:cNvPicPr>
+            <a:picLocks noChangeAspect="1"/>
+          </p:cNvPicPr>
+          <p:nvPr/>
+        </p:nvPicPr>
+        <p:blipFill>
+          <a:blip r:embed="rId4"/>
+          <a:stretch>
+            <a:fillRect/>
+          </a:stretch>
+        </p:blipFill>
+        <p:spPr>
+          <a:xfrm>
             <a:off x="11384280" y="164592"/>
             <a:ext cx="475488" cy="475488"/>
           </a:xfrm>
@@ -9823,7 +10123,7 @@
       </p:pic>
       <p:sp>
         <p:nvSpPr>
-          <p:cNvPr id="4" name="Rectangle 3"/>
+          <p:cNvPr id="5" name="Rectangle 4"/>
           <p:cNvSpPr/>
           <p:nvPr/>
         </p:nvSpPr>
@@ -9866,7 +10166,7 @@
       </p:sp>
       <p:sp>
         <p:nvSpPr>
-          <p:cNvPr id="5" name="Rectangle 4"/>
+          <p:cNvPr id="6" name="Rectangle 5"/>
           <p:cNvSpPr/>
           <p:nvPr/>
         </p:nvSpPr>
@@ -9909,7 +10209,7 @@
       </p:sp>
       <p:sp>
         <p:nvSpPr>
-          <p:cNvPr id="6" name="TextBox 5"/>
+          <p:cNvPr id="7" name="TextBox 6"/>
           <p:cNvSpPr txBox="1"/>
           <p:nvPr/>
         </p:nvSpPr>
@@ -9944,7 +10244,7 @@
       </p:sp>
       <p:sp>
         <p:nvSpPr>
-          <p:cNvPr id="7" name="TextBox 6"/>
+          <p:cNvPr id="8" name="TextBox 7"/>
           <p:cNvSpPr txBox="1"/>
           <p:nvPr/>
         </p:nvSpPr>
@@ -9979,7 +10279,7 @@
       </p:sp>
       <p:sp>
         <p:nvSpPr>
-          <p:cNvPr id="8" name="TextBox 7"/>
+          <p:cNvPr id="9" name="TextBox 8"/>
           <p:cNvSpPr txBox="1"/>
           <p:nvPr/>
         </p:nvSpPr>
@@ -10014,7 +10314,7 @@
       </p:sp>
       <p:sp>
         <p:nvSpPr>
-          <p:cNvPr id="9" name="TextBox 8"/>
+          <p:cNvPr id="10" name="TextBox 9"/>
           <p:cNvSpPr txBox="1"/>
           <p:nvPr/>
         </p:nvSpPr>
@@ -10183,7 +10483,7 @@
       </p:pic>
       <p:pic>
         <p:nvPicPr>
-          <p:cNvPr id="3" name="Picture 2" descr="cern-logo.svg.png"/>
+          <p:cNvPr id="3" name="Picture 2" descr="journalcache-logo.png"/>
           <p:cNvPicPr>
             <a:picLocks noChangeAspect="1"/>
           </p:cNvPicPr>
@@ -10197,6 +10497,30 @@
         </p:blipFill>
         <p:spPr>
           <a:xfrm>
+            <a:off x="960120" y="109728"/>
+            <a:ext cx="699496" cy="566928"/>
+          </a:xfrm>
+          <a:prstGeom prst="rect">
+            <a:avLst/>
+          </a:prstGeom>
+        </p:spPr>
+      </p:pic>
+      <p:pic>
+        <p:nvPicPr>
+          <p:cNvPr id="4" name="Picture 3" descr="cern-logo.svg.png"/>
+          <p:cNvPicPr>
+            <a:picLocks noChangeAspect="1"/>
+          </p:cNvPicPr>
+          <p:nvPr/>
+        </p:nvPicPr>
+        <p:blipFill>
+          <a:blip r:embed="rId4"/>
+          <a:stretch>
+            <a:fillRect/>
+          </a:stretch>
+        </p:blipFill>
+        <p:spPr>
+          <a:xfrm>
             <a:off x="11384280" y="164592"/>
             <a:ext cx="475488" cy="475488"/>
           </a:xfrm>
@@ -10207,7 +10531,7 @@
       </p:pic>
       <p:sp>
         <p:nvSpPr>
-          <p:cNvPr id="4" name="Rectangle 3"/>
+          <p:cNvPr id="5" name="Rectangle 4"/>
           <p:cNvSpPr/>
           <p:nvPr/>
         </p:nvSpPr>
@@ -10250,7 +10574,7 @@
       </p:sp>
       <p:sp>
         <p:nvSpPr>
-          <p:cNvPr id="5" name="Rectangle 4"/>
+          <p:cNvPr id="6" name="Rectangle 5"/>
           <p:cNvSpPr/>
           <p:nvPr/>
         </p:nvSpPr>
@@ -10293,7 +10617,7 @@
       </p:sp>
       <p:sp>
         <p:nvSpPr>
-          <p:cNvPr id="6" name="TextBox 5"/>
+          <p:cNvPr id="7" name="TextBox 6"/>
           <p:cNvSpPr txBox="1"/>
           <p:nvPr/>
         </p:nvSpPr>
@@ -10328,7 +10652,7 @@
       </p:sp>
       <p:sp>
         <p:nvSpPr>
-          <p:cNvPr id="7" name="TextBox 6"/>
+          <p:cNvPr id="8" name="TextBox 7"/>
           <p:cNvSpPr txBox="1"/>
           <p:nvPr/>
         </p:nvSpPr>
@@ -10363,7 +10687,7 @@
       </p:sp>
       <p:sp>
         <p:nvSpPr>
-          <p:cNvPr id="8" name="TextBox 7"/>
+          <p:cNvPr id="9" name="TextBox 8"/>
           <p:cNvSpPr txBox="1"/>
           <p:nvPr/>
         </p:nvSpPr>
@@ -10398,7 +10722,7 @@
       </p:sp>
       <p:sp>
         <p:nvSpPr>
-          <p:cNvPr id="9" name="TextBox 8"/>
+          <p:cNvPr id="10" name="TextBox 9"/>
           <p:cNvSpPr txBox="1"/>
           <p:nvPr/>
         </p:nvSpPr>
@@ -10433,7 +10757,7 @@
       </p:sp>
       <p:sp>
         <p:nvSpPr>
-          <p:cNvPr id="10" name="Rounded Rectangle 9"/>
+          <p:cNvPr id="11" name="Rounded Rectangle 10"/>
           <p:cNvSpPr/>
           <p:nvPr/>
         </p:nvSpPr>
@@ -10478,7 +10802,7 @@
       </p:sp>
       <p:sp>
         <p:nvSpPr>
-          <p:cNvPr id="11" name="TextBox 10"/>
+          <p:cNvPr id="12" name="TextBox 11"/>
           <p:cNvSpPr txBox="1"/>
           <p:nvPr/>
         </p:nvSpPr>
@@ -10513,7 +10837,7 @@
       </p:sp>
       <p:sp>
         <p:nvSpPr>
-          <p:cNvPr id="12" name="TextBox 11"/>
+          <p:cNvPr id="13" name="TextBox 12"/>
           <p:cNvSpPr txBox="1"/>
           <p:nvPr/>
         </p:nvSpPr>
@@ -10548,7 +10872,7 @@
       </p:sp>
       <p:sp>
         <p:nvSpPr>
-          <p:cNvPr id="13" name="TextBox 12"/>
+          <p:cNvPr id="14" name="TextBox 13"/>
           <p:cNvSpPr txBox="1"/>
           <p:nvPr/>
         </p:nvSpPr>
@@ -10635,7 +10959,7 @@
       </p:sp>
       <p:sp>
         <p:nvSpPr>
-          <p:cNvPr id="14" name="Rounded Rectangle 13"/>
+          <p:cNvPr id="15" name="Rounded Rectangle 14"/>
           <p:cNvSpPr/>
           <p:nvPr/>
         </p:nvSpPr>
@@ -10680,7 +11004,7 @@
       </p:sp>
       <p:sp>
         <p:nvSpPr>
-          <p:cNvPr id="15" name="TextBox 14"/>
+          <p:cNvPr id="16" name="TextBox 15"/>
           <p:cNvSpPr txBox="1"/>
           <p:nvPr/>
         </p:nvSpPr>
@@ -10715,7 +11039,7 @@
       </p:sp>
       <p:sp>
         <p:nvSpPr>
-          <p:cNvPr id="16" name="TextBox 15"/>
+          <p:cNvPr id="17" name="TextBox 16"/>
           <p:cNvSpPr txBox="1"/>
           <p:nvPr/>
         </p:nvSpPr>
@@ -10750,7 +11074,7 @@
       </p:sp>
       <p:sp>
         <p:nvSpPr>
-          <p:cNvPr id="17" name="TextBox 16"/>
+          <p:cNvPr id="18" name="TextBox 17"/>
           <p:cNvSpPr txBox="1"/>
           <p:nvPr/>
         </p:nvSpPr>
@@ -10887,7 +11211,7 @@
       </p:pic>
       <p:pic>
         <p:nvPicPr>
-          <p:cNvPr id="3" name="Picture 2" descr="cern-logo.svg.png"/>
+          <p:cNvPr id="3" name="Picture 2" descr="journalcache-logo.png"/>
           <p:cNvPicPr>
             <a:picLocks noChangeAspect="1"/>
           </p:cNvPicPr>
@@ -10901,6 +11225,30 @@
         </p:blipFill>
         <p:spPr>
           <a:xfrm>
+            <a:off x="960120" y="109728"/>
+            <a:ext cx="699496" cy="566928"/>
+          </a:xfrm>
+          <a:prstGeom prst="rect">
+            <a:avLst/>
+          </a:prstGeom>
+        </p:spPr>
+      </p:pic>
+      <p:pic>
+        <p:nvPicPr>
+          <p:cNvPr id="4" name="Picture 3" descr="cern-logo.svg.png"/>
+          <p:cNvPicPr>
+            <a:picLocks noChangeAspect="1"/>
+          </p:cNvPicPr>
+          <p:nvPr/>
+        </p:nvPicPr>
+        <p:blipFill>
+          <a:blip r:embed="rId4"/>
+          <a:stretch>
+            <a:fillRect/>
+          </a:stretch>
+        </p:blipFill>
+        <p:spPr>
+          <a:xfrm>
             <a:off x="11384280" y="164592"/>
             <a:ext cx="475488" cy="475488"/>
           </a:xfrm>
@@ -10911,7 +11259,7 @@
       </p:pic>
       <p:sp>
         <p:nvSpPr>
-          <p:cNvPr id="4" name="Rectangle 3"/>
+          <p:cNvPr id="5" name="Rectangle 4"/>
           <p:cNvSpPr/>
           <p:nvPr/>
         </p:nvSpPr>
@@ -10954,7 +11302,7 @@
       </p:sp>
       <p:sp>
         <p:nvSpPr>
-          <p:cNvPr id="5" name="Rectangle 4"/>
+          <p:cNvPr id="6" name="Rectangle 5"/>
           <p:cNvSpPr/>
           <p:nvPr/>
         </p:nvSpPr>
@@ -10997,7 +11345,7 @@
       </p:sp>
       <p:sp>
         <p:nvSpPr>
-          <p:cNvPr id="6" name="TextBox 5"/>
+          <p:cNvPr id="7" name="TextBox 6"/>
           <p:cNvSpPr txBox="1"/>
           <p:nvPr/>
         </p:nvSpPr>
@@ -11032,7 +11380,7 @@
       </p:sp>
       <p:sp>
         <p:nvSpPr>
-          <p:cNvPr id="7" name="TextBox 6"/>
+          <p:cNvPr id="8" name="TextBox 7"/>
           <p:cNvSpPr txBox="1"/>
           <p:nvPr/>
         </p:nvSpPr>
@@ -11067,7 +11415,7 @@
       </p:sp>
       <p:sp>
         <p:nvSpPr>
-          <p:cNvPr id="8" name="TextBox 7"/>
+          <p:cNvPr id="9" name="TextBox 8"/>
           <p:cNvSpPr txBox="1"/>
           <p:nvPr/>
         </p:nvSpPr>
@@ -11102,7 +11450,7 @@
       </p:sp>
       <p:sp>
         <p:nvSpPr>
-          <p:cNvPr id="9" name="TextBox 8"/>
+          <p:cNvPr id="10" name="TextBox 9"/>
           <p:cNvSpPr txBox="1"/>
           <p:nvPr/>
         </p:nvSpPr>
@@ -11137,7 +11485,7 @@
       </p:sp>
       <p:sp>
         <p:nvSpPr>
-          <p:cNvPr id="10" name="Rounded Rectangle 9"/>
+          <p:cNvPr id="11" name="Rounded Rectangle 10"/>
           <p:cNvSpPr/>
           <p:nvPr/>
         </p:nvSpPr>
@@ -11182,7 +11530,7 @@
       </p:sp>
       <p:sp>
         <p:nvSpPr>
-          <p:cNvPr id="11" name="TextBox 10"/>
+          <p:cNvPr id="12" name="TextBox 11"/>
           <p:cNvSpPr txBox="1"/>
           <p:nvPr/>
         </p:nvSpPr>
@@ -11210,14 +11558,14 @@
                 </a:solidFill>
                 <a:latin typeface="Calibri"/>
               </a:rPr>
-              <a:t>Hit — serve from journal</a:t>
-            </a:r>
-          </a:p>
-        </p:txBody>
-      </p:sp>
-      <p:sp>
-        <p:nvSpPr>
-          <p:cNvPr id="12" name="TextBox 11"/>
+              <a:t>Hit - serve from journal</a:t>
+            </a:r>
+          </a:p>
+        </p:txBody>
+      </p:sp>
+      <p:sp>
+        <p:nvSpPr>
+          <p:cNvPr id="13" name="TextBox 12"/>
           <p:cNvSpPr txBox="1"/>
           <p:nvPr/>
         </p:nvSpPr>
@@ -11304,7 +11652,7 @@
       </p:sp>
       <p:sp>
         <p:nvSpPr>
-          <p:cNvPr id="13" name="Rounded Rectangle 12"/>
+          <p:cNvPr id="14" name="Rounded Rectangle 13"/>
           <p:cNvSpPr/>
           <p:nvPr/>
         </p:nvSpPr>
@@ -11349,7 +11697,7 @@
       </p:sp>
       <p:sp>
         <p:nvSpPr>
-          <p:cNvPr id="14" name="TextBox 13"/>
+          <p:cNvPr id="15" name="TextBox 14"/>
           <p:cNvSpPr txBox="1"/>
           <p:nvPr/>
         </p:nvSpPr>
@@ -11377,14 +11725,14 @@
                 </a:solidFill>
                 <a:latin typeface="Calibri"/>
               </a:rPr>
-              <a:t>Miss — fetch, then append</a:t>
-            </a:r>
-          </a:p>
-        </p:txBody>
-      </p:sp>
-      <p:sp>
-        <p:nvSpPr>
-          <p:cNvPr id="15" name="TextBox 14"/>
+              <a:t>Miss - fetch, then append</a:t>
+            </a:r>
+          </a:p>
+        </p:txBody>
+      </p:sp>
+      <p:sp>
+        <p:nvSpPr>
+          <p:cNvPr id="16" name="TextBox 15"/>
           <p:cNvSpPr txBox="1"/>
           <p:nvPr/>
         </p:nvSpPr>
@@ -11521,7 +11869,7 @@
       </p:pic>
       <p:pic>
         <p:nvPicPr>
-          <p:cNvPr id="3" name="Picture 2" descr="cern-logo.svg.png"/>
+          <p:cNvPr id="3" name="Picture 2" descr="journalcache-logo.png"/>
           <p:cNvPicPr>
             <a:picLocks noChangeAspect="1"/>
           </p:cNvPicPr>
@@ -11535,6 +11883,30 @@
         </p:blipFill>
         <p:spPr>
           <a:xfrm>
+            <a:off x="960120" y="109728"/>
+            <a:ext cx="699496" cy="566928"/>
+          </a:xfrm>
+          <a:prstGeom prst="rect">
+            <a:avLst/>
+          </a:prstGeom>
+        </p:spPr>
+      </p:pic>
+      <p:pic>
+        <p:nvPicPr>
+          <p:cNvPr id="4" name="Picture 3" descr="cern-logo.svg.png"/>
+          <p:cNvPicPr>
+            <a:picLocks noChangeAspect="1"/>
+          </p:cNvPicPr>
+          <p:nvPr/>
+        </p:nvPicPr>
+        <p:blipFill>
+          <a:blip r:embed="rId4"/>
+          <a:stretch>
+            <a:fillRect/>
+          </a:stretch>
+        </p:blipFill>
+        <p:spPr>
+          <a:xfrm>
             <a:off x="11384280" y="164592"/>
             <a:ext cx="475488" cy="475488"/>
           </a:xfrm>
@@ -11545,7 +11917,7 @@
       </p:pic>
       <p:sp>
         <p:nvSpPr>
-          <p:cNvPr id="4" name="Rectangle 3"/>
+          <p:cNvPr id="5" name="Rectangle 4"/>
           <p:cNvSpPr/>
           <p:nvPr/>
         </p:nvSpPr>
@@ -11588,7 +11960,7 @@
       </p:sp>
       <p:sp>
         <p:nvSpPr>
-          <p:cNvPr id="5" name="Rectangle 4"/>
+          <p:cNvPr id="6" name="Rectangle 5"/>
           <p:cNvSpPr/>
           <p:nvPr/>
         </p:nvSpPr>
@@ -11631,7 +12003,7 @@
       </p:sp>
       <p:sp>
         <p:nvSpPr>
-          <p:cNvPr id="6" name="TextBox 5"/>
+          <p:cNvPr id="7" name="TextBox 6"/>
           <p:cNvSpPr txBox="1"/>
           <p:nvPr/>
         </p:nvSpPr>
@@ -11666,7 +12038,7 @@
       </p:sp>
       <p:sp>
         <p:nvSpPr>
-          <p:cNvPr id="7" name="TextBox 6"/>
+          <p:cNvPr id="8" name="TextBox 7"/>
           <p:cNvSpPr txBox="1"/>
           <p:nvPr/>
         </p:nvSpPr>
@@ -11701,7 +12073,7 @@
       </p:sp>
       <p:sp>
         <p:nvSpPr>
-          <p:cNvPr id="8" name="TextBox 7"/>
+          <p:cNvPr id="9" name="TextBox 8"/>
           <p:cNvSpPr txBox="1"/>
           <p:nvPr/>
         </p:nvSpPr>
@@ -11736,7 +12108,7 @@
       </p:sp>
       <p:graphicFrame>
         <p:nvGraphicFramePr>
-          <p:cNvPr id="9" name="Table 8"/>
+          <p:cNvPr id="10" name="Table 9"/>
           <p:cNvGraphicFramePr>
             <a:graphicFrameLocks noGrp="1"/>
           </p:cNvGraphicFramePr>
@@ -12148,7 +12520,7 @@
       </p:pic>
       <p:pic>
         <p:nvPicPr>
-          <p:cNvPr id="3" name="Picture 2" descr="cern-logo.svg.png"/>
+          <p:cNvPr id="3" name="Picture 2" descr="journalcache-logo.png"/>
           <p:cNvPicPr>
             <a:picLocks noChangeAspect="1"/>
           </p:cNvPicPr>
@@ -12162,6 +12534,30 @@
         </p:blipFill>
         <p:spPr>
           <a:xfrm>
+            <a:off x="960120" y="109728"/>
+            <a:ext cx="699496" cy="566928"/>
+          </a:xfrm>
+          <a:prstGeom prst="rect">
+            <a:avLst/>
+          </a:prstGeom>
+        </p:spPr>
+      </p:pic>
+      <p:pic>
+        <p:nvPicPr>
+          <p:cNvPr id="4" name="Picture 3" descr="cern-logo.svg.png"/>
+          <p:cNvPicPr>
+            <a:picLocks noChangeAspect="1"/>
+          </p:cNvPicPr>
+          <p:nvPr/>
+        </p:nvPicPr>
+        <p:blipFill>
+          <a:blip r:embed="rId4"/>
+          <a:stretch>
+            <a:fillRect/>
+          </a:stretch>
+        </p:blipFill>
+        <p:spPr>
+          <a:xfrm>
             <a:off x="11384280" y="164592"/>
             <a:ext cx="475488" cy="475488"/>
           </a:xfrm>
@@ -12172,7 +12568,7 @@
       </p:pic>
       <p:sp>
         <p:nvSpPr>
-          <p:cNvPr id="4" name="Rectangle 3"/>
+          <p:cNvPr id="5" name="Rectangle 4"/>
           <p:cNvSpPr/>
           <p:nvPr/>
         </p:nvSpPr>
@@ -12215,7 +12611,7 @@
       </p:sp>
       <p:sp>
         <p:nvSpPr>
-          <p:cNvPr id="5" name="Rectangle 4"/>
+          <p:cNvPr id="6" name="Rectangle 5"/>
           <p:cNvSpPr/>
           <p:nvPr/>
         </p:nvSpPr>
@@ -12258,7 +12654,7 @@
       </p:sp>
       <p:sp>
         <p:nvSpPr>
-          <p:cNvPr id="6" name="TextBox 5"/>
+          <p:cNvPr id="7" name="TextBox 6"/>
           <p:cNvSpPr txBox="1"/>
           <p:nvPr/>
         </p:nvSpPr>
@@ -12293,7 +12689,7 @@
       </p:sp>
       <p:sp>
         <p:nvSpPr>
-          <p:cNvPr id="7" name="TextBox 6"/>
+          <p:cNvPr id="8" name="TextBox 7"/>
           <p:cNvSpPr txBox="1"/>
           <p:nvPr/>
         </p:nvSpPr>
@@ -12328,7 +12724,7 @@
       </p:sp>
       <p:sp>
         <p:nvSpPr>
-          <p:cNvPr id="8" name="TextBox 7"/>
+          <p:cNvPr id="9" name="TextBox 8"/>
           <p:cNvSpPr txBox="1"/>
           <p:nvPr/>
         </p:nvSpPr>
@@ -12363,7 +12759,7 @@
       </p:sp>
       <p:sp>
         <p:nvSpPr>
-          <p:cNvPr id="9" name="Rounded Rectangle 8"/>
+          <p:cNvPr id="10" name="Rounded Rectangle 9"/>
           <p:cNvSpPr/>
           <p:nvPr/>
         </p:nvSpPr>
@@ -12408,7 +12804,7 @@
       </p:sp>
       <p:sp>
         <p:nvSpPr>
-          <p:cNvPr id="10" name="TextBox 9"/>
+          <p:cNvPr id="11" name="TextBox 10"/>
           <p:cNvSpPr txBox="1"/>
           <p:nvPr/>
         </p:nvSpPr>
@@ -12443,7 +12839,7 @@
       </p:sp>
       <p:sp>
         <p:nvSpPr>
-          <p:cNvPr id="11" name="TextBox 10"/>
+          <p:cNvPr id="12" name="TextBox 11"/>
           <p:cNvSpPr txBox="1"/>
           <p:nvPr/>
         </p:nvSpPr>
@@ -12491,7 +12887,7 @@
                 </a:solidFill>
                 <a:latin typeface="Calibri"/>
               </a:rPr>
-              <a:t>• flat = true — SHA256 directory per file</a:t>
+              <a:t>• flat = true - SHA256 directory per file</a:t>
             </a:r>
           </a:p>
           <a:p>
@@ -12507,7 +12903,7 @@
                 </a:solidFill>
                 <a:latin typeface="Calibri"/>
               </a:rPr>
-              <a:t>• basepath = /store/ — omit the host; start at the federation prefix</a:t>
+              <a:t>• basepath = /store/ - omit the host; start at the federation prefix</a:t>
             </a:r>
           </a:p>
           <a:p>
@@ -12546,7 +12942,7 @@
       </p:sp>
       <p:sp>
         <p:nvSpPr>
-          <p:cNvPr id="12" name="Rounded Rectangle 11"/>
+          <p:cNvPr id="13" name="Rounded Rectangle 12"/>
           <p:cNvSpPr/>
           <p:nvPr/>
         </p:nvSpPr>
@@ -12591,7 +12987,7 @@
       </p:sp>
       <p:sp>
         <p:nvSpPr>
-          <p:cNvPr id="13" name="TextBox 12"/>
+          <p:cNvPr id="14" name="TextBox 13"/>
           <p:cNvSpPr txBox="1"/>
           <p:nvPr/>
         </p:nvSpPr>
@@ -12626,7 +13022,7 @@
       </p:sp>
       <p:sp>
         <p:nvSpPr>
-          <p:cNvPr id="14" name="TextBox 13"/>
+          <p:cNvPr id="15" name="TextBox 14"/>
           <p:cNvSpPr txBox="1"/>
           <p:nvPr/>
         </p:nvSpPr>
@@ -12658,7 +13054,7 @@
                 </a:solidFill>
                 <a:latin typeface="Calibri"/>
               </a:rPr>
-              <a:t>• jheader_t — magic, mtime, filesize, version</a:t>
+              <a:t>• jheader_t - magic, mtime, filesize, version</a:t>
             </a:r>
           </a:p>
           <a:p>
@@ -12729,7 +13125,7 @@
       </p:sp>
       <p:sp>
         <p:nvSpPr>
-          <p:cNvPr id="15" name="TextBox 14"/>
+          <p:cNvPr id="16" name="TextBox 15"/>
           <p:cNvSpPr txBox="1"/>
           <p:nvPr/>
         </p:nvSpPr>
@@ -12814,7 +13210,7 @@
       </p:pic>
       <p:pic>
         <p:nvPicPr>
-          <p:cNvPr id="3" name="Picture 2" descr="cern-logo.svg.png"/>
+          <p:cNvPr id="3" name="Picture 2" descr="journalcache-logo.png"/>
           <p:cNvPicPr>
             <a:picLocks noChangeAspect="1"/>
           </p:cNvPicPr>
@@ -12828,6 +13224,30 @@
         </p:blipFill>
         <p:spPr>
           <a:xfrm>
+            <a:off x="960120" y="109728"/>
+            <a:ext cx="699496" cy="566928"/>
+          </a:xfrm>
+          <a:prstGeom prst="rect">
+            <a:avLst/>
+          </a:prstGeom>
+        </p:spPr>
+      </p:pic>
+      <p:pic>
+        <p:nvPicPr>
+          <p:cNvPr id="4" name="Picture 3" descr="cern-logo.svg.png"/>
+          <p:cNvPicPr>
+            <a:picLocks noChangeAspect="1"/>
+          </p:cNvPicPr>
+          <p:nvPr/>
+        </p:nvPicPr>
+        <p:blipFill>
+          <a:blip r:embed="rId4"/>
+          <a:stretch>
+            <a:fillRect/>
+          </a:stretch>
+        </p:blipFill>
+        <p:spPr>
+          <a:xfrm>
             <a:off x="11384280" y="164592"/>
             <a:ext cx="475488" cy="475488"/>
           </a:xfrm>
@@ -12838,7 +13258,7 @@
       </p:pic>
       <p:sp>
         <p:nvSpPr>
-          <p:cNvPr id="4" name="Rectangle 3"/>
+          <p:cNvPr id="5" name="Rectangle 4"/>
           <p:cNvSpPr/>
           <p:nvPr/>
         </p:nvSpPr>
@@ -12881,7 +13301,7 @@
       </p:sp>
       <p:sp>
         <p:nvSpPr>
-          <p:cNvPr id="5" name="Rectangle 4"/>
+          <p:cNvPr id="6" name="Rectangle 5"/>
           <p:cNvSpPr/>
           <p:nvPr/>
         </p:nvSpPr>
@@ -12924,7 +13344,7 @@
       </p:sp>
       <p:sp>
         <p:nvSpPr>
-          <p:cNvPr id="6" name="TextBox 5"/>
+          <p:cNvPr id="7" name="TextBox 6"/>
           <p:cNvSpPr txBox="1"/>
           <p:nvPr/>
         </p:nvSpPr>
@@ -12959,7 +13379,7 @@
       </p:sp>
       <p:sp>
         <p:nvSpPr>
-          <p:cNvPr id="7" name="TextBox 6"/>
+          <p:cNvPr id="8" name="TextBox 7"/>
           <p:cNvSpPr txBox="1"/>
           <p:nvPr/>
         </p:nvSpPr>
@@ -12994,7 +13414,7 @@
       </p:sp>
       <p:sp>
         <p:nvSpPr>
-          <p:cNvPr id="8" name="TextBox 7"/>
+          <p:cNvPr id="9" name="TextBox 8"/>
           <p:cNvSpPr txBox="1"/>
           <p:nvPr/>
         </p:nvSpPr>
@@ -13029,7 +13449,7 @@
       </p:sp>
       <p:sp>
         <p:nvSpPr>
-          <p:cNvPr id="9" name="TextBox 8"/>
+          <p:cNvPr id="10" name="TextBox 9"/>
           <p:cNvSpPr txBox="1"/>
           <p:nvPr/>
         </p:nvSpPr>
@@ -13064,7 +13484,7 @@
       </p:sp>
       <p:sp>
         <p:nvSpPr>
-          <p:cNvPr id="10" name="Rounded Rectangle 9"/>
+          <p:cNvPr id="11" name="Rounded Rectangle 10"/>
           <p:cNvSpPr/>
           <p:nvPr/>
         </p:nvSpPr>
@@ -13109,7 +13529,7 @@
       </p:sp>
       <p:sp>
         <p:nvSpPr>
-          <p:cNvPr id="11" name="TextBox 10"/>
+          <p:cNvPr id="12" name="TextBox 11"/>
           <p:cNvSpPr txBox="1"/>
           <p:nvPr/>
         </p:nvSpPr>
@@ -13144,7 +13564,7 @@
       </p:sp>
       <p:sp>
         <p:nvSpPr>
-          <p:cNvPr id="12" name="TextBox 11"/>
+          <p:cNvPr id="13" name="TextBox 12"/>
           <p:cNvSpPr txBox="1"/>
           <p:nvPr/>
         </p:nvSpPr>
@@ -13176,7 +13596,7 @@
                 </a:solidFill>
                 <a:latin typeface="Calibri"/>
               </a:rPr>
-              <a:t>• no-store — do not journal</a:t>
+              <a:t>• no-store - do not journal</a:t>
             </a:r>
           </a:p>
           <a:p>
@@ -13192,7 +13612,7 @@
                 </a:solidFill>
                 <a:latin typeface="Calibri"/>
               </a:rPr>
-              <a:t>• no-cache — Stat this session before serving</a:t>
+              <a:t>• no-cache - Stat this session before serving</a:t>
             </a:r>
           </a:p>
           <a:p>
@@ -13208,7 +13628,7 @@
                 </a:solidFill>
                 <a:latin typeface="Calibri"/>
               </a:rPr>
-              <a:t>• private — do not write the shared journal</a:t>
+              <a:t>• private - do not write the shared journal</a:t>
             </a:r>
           </a:p>
           <a:p>
@@ -13224,14 +13644,14 @@
                 </a:solidFill>
                 <a:latin typeface="Calibri"/>
               </a:rPr>
-              <a:t>• max-age / s-maxage / Expires — expire from cached-at</a:t>
-            </a:r>
-          </a:p>
-        </p:txBody>
-      </p:sp>
-      <p:sp>
-        <p:nvSpPr>
-          <p:cNvPr id="13" name="Rounded Rectangle 12"/>
+              <a:t>• max-age / s-maxage / Expires - expire from cached-at</a:t>
+            </a:r>
+          </a:p>
+        </p:txBody>
+      </p:sp>
+      <p:sp>
+        <p:nvSpPr>
+          <p:cNvPr id="14" name="Rounded Rectangle 13"/>
           <p:cNvSpPr/>
           <p:nvPr/>
         </p:nvSpPr>
@@ -13276,7 +13696,7 @@
       </p:sp>
       <p:sp>
         <p:nvSpPr>
-          <p:cNvPr id="14" name="TextBox 13"/>
+          <p:cNvPr id="15" name="TextBox 14"/>
           <p:cNvSpPr txBox="1"/>
           <p:nvPr/>
         </p:nvSpPr>
@@ -13311,7 +13731,7 @@
       </p:sp>
       <p:sp>
         <p:nvSpPr>
-          <p:cNvPr id="15" name="TextBox 14"/>
+          <p:cNvPr id="16" name="TextBox 15"/>
           <p:cNvSpPr txBox="1"/>
           <p:nvPr/>
         </p:nvSpPr>
@@ -13464,7 +13884,7 @@
       </p:pic>
       <p:pic>
         <p:nvPicPr>
-          <p:cNvPr id="3" name="Picture 2" descr="cern-logo.svg.png"/>
+          <p:cNvPr id="3" name="Picture 2" descr="journalcache-logo.png"/>
           <p:cNvPicPr>
             <a:picLocks noChangeAspect="1"/>
           </p:cNvPicPr>
@@ -13478,6 +13898,30 @@
         </p:blipFill>
         <p:spPr>
           <a:xfrm>
+            <a:off x="960120" y="109728"/>
+            <a:ext cx="699496" cy="566928"/>
+          </a:xfrm>
+          <a:prstGeom prst="rect">
+            <a:avLst/>
+          </a:prstGeom>
+        </p:spPr>
+      </p:pic>
+      <p:pic>
+        <p:nvPicPr>
+          <p:cNvPr id="4" name="Picture 3" descr="cern-logo.svg.png"/>
+          <p:cNvPicPr>
+            <a:picLocks noChangeAspect="1"/>
+          </p:cNvPicPr>
+          <p:nvPr/>
+        </p:nvPicPr>
+        <p:blipFill>
+          <a:blip r:embed="rId4"/>
+          <a:stretch>
+            <a:fillRect/>
+          </a:stretch>
+        </p:blipFill>
+        <p:spPr>
+          <a:xfrm>
             <a:off x="11384280" y="164592"/>
             <a:ext cx="475488" cy="475488"/>
           </a:xfrm>
@@ -13488,7 +13932,7 @@
       </p:pic>
       <p:sp>
         <p:nvSpPr>
-          <p:cNvPr id="4" name="Rectangle 3"/>
+          <p:cNvPr id="5" name="Rectangle 4"/>
           <p:cNvSpPr/>
           <p:nvPr/>
         </p:nvSpPr>
@@ -13531,7 +13975,7 @@
       </p:sp>
       <p:sp>
         <p:nvSpPr>
-          <p:cNvPr id="5" name="Rectangle 4"/>
+          <p:cNvPr id="6" name="Rectangle 5"/>
           <p:cNvSpPr/>
           <p:nvPr/>
         </p:nvSpPr>
@@ -13574,7 +14018,7 @@
       </p:sp>
       <p:sp>
         <p:nvSpPr>
-          <p:cNvPr id="6" name="TextBox 5"/>
+          <p:cNvPr id="7" name="TextBox 6"/>
           <p:cNvSpPr txBox="1"/>
           <p:nvPr/>
         </p:nvSpPr>
@@ -13609,7 +14053,7 @@
       </p:sp>
       <p:sp>
         <p:nvSpPr>
-          <p:cNvPr id="7" name="TextBox 6"/>
+          <p:cNvPr id="8" name="TextBox 7"/>
           <p:cNvSpPr txBox="1"/>
           <p:nvPr/>
         </p:nvSpPr>
@@ -13644,7 +14088,7 @@
       </p:sp>
       <p:sp>
         <p:nvSpPr>
-          <p:cNvPr id="8" name="TextBox 7"/>
+          <p:cNvPr id="9" name="TextBox 8"/>
           <p:cNvSpPr txBox="1"/>
           <p:nvPr/>
         </p:nvSpPr>
@@ -13679,7 +14123,7 @@
       </p:sp>
       <p:sp>
         <p:nvSpPr>
-          <p:cNvPr id="9" name="TextBox 8"/>
+          <p:cNvPr id="10" name="TextBox 9"/>
           <p:cNvSpPr txBox="1"/>
           <p:nvPr/>
         </p:nvSpPr>
@@ -13714,7 +14158,7 @@
       </p:sp>
       <p:sp>
         <p:nvSpPr>
-          <p:cNvPr id="10" name="Rounded Rectangle 9"/>
+          <p:cNvPr id="11" name="Rounded Rectangle 10"/>
           <p:cNvSpPr/>
           <p:nvPr/>
         </p:nvSpPr>
@@ -13759,7 +14203,7 @@
       </p:sp>
       <p:sp>
         <p:nvSpPr>
-          <p:cNvPr id="11" name="TextBox 10"/>
+          <p:cNvPr id="12" name="TextBox 11"/>
           <p:cNvSpPr txBox="1"/>
           <p:nvPr/>
         </p:nvSpPr>
@@ -13794,7 +14238,7 @@
       </p:sp>
       <p:sp>
         <p:nvSpPr>
-          <p:cNvPr id="12" name="TextBox 11"/>
+          <p:cNvPr id="13" name="TextBox 12"/>
           <p:cNvSpPr txBox="1"/>
           <p:nvPr/>
         </p:nvSpPr>
@@ -13849,7 +14293,7 @@
       </p:sp>
       <p:sp>
         <p:nvSpPr>
-          <p:cNvPr id="13" name="Rounded Rectangle 12"/>
+          <p:cNvPr id="14" name="Rounded Rectangle 13"/>
           <p:cNvSpPr/>
           <p:nvPr/>
         </p:nvSpPr>
@@ -13894,7 +14338,7 @@
       </p:sp>
       <p:sp>
         <p:nvSpPr>
-          <p:cNvPr id="14" name="TextBox 13"/>
+          <p:cNvPr id="15" name="TextBox 14"/>
           <p:cNvSpPr txBox="1"/>
           <p:nvPr/>
         </p:nvSpPr>
@@ -13922,14 +14366,14 @@
                 </a:solidFill>
                 <a:latin typeface="Calibri"/>
               </a:rPr>
-              <a:t>Deny — 403</a:t>
-            </a:r>
-          </a:p>
-        </p:txBody>
-      </p:sp>
-      <p:sp>
-        <p:nvSpPr>
-          <p:cNvPr id="15" name="TextBox 14"/>
+              <a:t>Deny - 403</a:t>
+            </a:r>
+          </a:p>
+        </p:txBody>
+      </p:sp>
+      <p:sp>
+        <p:nvSpPr>
+          <p:cNvPr id="16" name="TextBox 15"/>
           <p:cNvSpPr txBox="1"/>
           <p:nvPr/>
         </p:nvSpPr>
@@ -13984,7 +14428,7 @@
       </p:sp>
       <p:sp>
         <p:nvSpPr>
-          <p:cNvPr id="16" name="Rounded Rectangle 15"/>
+          <p:cNvPr id="17" name="Rounded Rectangle 16"/>
           <p:cNvSpPr/>
           <p:nvPr/>
         </p:nvSpPr>
@@ -14029,7 +14473,7 @@
       </p:sp>
       <p:sp>
         <p:nvSpPr>
-          <p:cNvPr id="17" name="TextBox 16"/>
+          <p:cNvPr id="18" name="TextBox 17"/>
           <p:cNvSpPr txBox="1"/>
           <p:nvPr/>
         </p:nvSpPr>
@@ -14064,7 +14508,7 @@
       </p:sp>
       <p:sp>
         <p:nvSpPr>
-          <p:cNvPr id="18" name="TextBox 17"/>
+          <p:cNvPr id="19" name="TextBox 18"/>
           <p:cNvSpPr txBox="1"/>
           <p:nvPr/>
         </p:nvSpPr>

</xml_diff>